<commit_message>
fix(ci): use a pinned S3 test service
</commit_message>
<xml_diff>
--- a/docs/presentations/Corpusil_Architecture_Slide.pptx
+++ b/docs/presentations/Corpusil_Architecture_Slide.pptx
@@ -1946,7 +1946,7 @@
                 <a:ea typeface="Calibri" pitchFamily="34" charset="-122"/>
                 <a:cs typeface="Calibri" pitchFamily="34" charset="-120"/>
               </a:rPr>
-              <a:t>Case Dispatch</a:t>
+              <a:t>Case &amp; Investigation Routers</a:t>
             </a:r>
             <a:endParaRPr lang="en-US" sz="1050" dirty="0"/>
           </a:p>
@@ -1985,7 +1985,7 @@
                 <a:ea typeface="Calibri" pitchFamily="34" charset="-122"/>
                 <a:cs typeface="Calibri" pitchFamily="34" charset="-120"/>
               </a:rPr>
-              <a:t>opens a case workspace</a:t>
+              <a:t>cases · investigation · document_analysis</a:t>
             </a:r>
             <a:endParaRPr lang="en-US" sz="800" dirty="0"/>
           </a:p>
@@ -2114,7 +2114,7 @@
         <p:spPr>
           <a:xfrm>
             <a:off x="457200" y="2346960"/>
-            <a:ext cx="3307080" cy="121920"/>
+            <a:ext cx="2026920" cy="121920"/>
           </a:xfrm>
           <a:prstGeom prst="rect">
             <a:avLst/>
@@ -2146,7 +2146,46 @@
       </p:sp>
       <p:sp>
         <p:nvSpPr>
-          <p:cNvPr id="40" name="Shape 38"/>
+          <p:cNvPr id="40" name="Text 38"/>
+          <p:cNvSpPr txBox="1"/>
+          <p:nvPr/>
+        </p:nvSpPr>
+        <p:spPr>
+          <a:xfrm>
+            <a:off x="2362200" y="2346960"/>
+            <a:ext cx="1417320" cy="121920"/>
+          </a:xfrm>
+          <a:prstGeom prst="rect">
+            <a:avLst/>
+          </a:prstGeom>
+          <a:noFill/>
+          <a:ln/>
+        </p:spPr>
+        <p:txBody>
+          <a:bodyPr wrap="square" lIns="0" tIns="0" rIns="0" bIns="0" rtlCol="0" anchor="ctr"/>
+          <a:lstStyle/>
+          <a:p>
+            <a:pPr algn="r" indent="0" marL="0">
+              <a:buNone/>
+            </a:pPr>
+            <a:r>
+              <a:rPr lang="en-US" sz="750" b="1" dirty="0">
+                <a:solidFill>
+                  <a:srgbClr val="DC2626"/>
+                </a:solidFill>
+                <a:latin typeface="Calibri" pitchFamily="34" charset="0"/>
+                <a:ea typeface="Calibri" pitchFamily="34" charset="-122"/>
+                <a:cs typeface="Calibri" pitchFamily="34" charset="-120"/>
+              </a:rPr>
+              <a:t>NO LLM · NO RERANK</a:t>
+            </a:r>
+            <a:endParaRPr lang="en-US" sz="750" dirty="0"/>
+          </a:p>
+        </p:txBody>
+      </p:sp>
+      <p:sp>
+        <p:nvSpPr>
+          <p:cNvPr id="41" name="Shape 39"/>
           <p:cNvSpPr/>
           <p:nvPr/>
         </p:nvSpPr>
@@ -2173,14 +2212,14 @@
       </p:sp>
       <p:sp>
         <p:nvSpPr>
-          <p:cNvPr id="41" name="Text 39"/>
+          <p:cNvPr id="42" name="Text 40"/>
           <p:cNvSpPr txBox="1"/>
           <p:nvPr/>
         </p:nvSpPr>
         <p:spPr>
           <a:xfrm>
             <a:off x="4434840" y="2346960"/>
-            <a:ext cx="3307080" cy="121920"/>
+            <a:ext cx="2026920" cy="121920"/>
           </a:xfrm>
           <a:prstGeom prst="rect">
             <a:avLst/>
@@ -2212,7 +2251,46 @@
       </p:sp>
       <p:sp>
         <p:nvSpPr>
-          <p:cNvPr id="42" name="Shape 40"/>
+          <p:cNvPr id="43" name="Text 41"/>
+          <p:cNvSpPr txBox="1"/>
+          <p:nvPr/>
+        </p:nvSpPr>
+        <p:spPr>
+          <a:xfrm>
+            <a:off x="6339840" y="2346960"/>
+            <a:ext cx="1417320" cy="121920"/>
+          </a:xfrm>
+          <a:prstGeom prst="rect">
+            <a:avLst/>
+          </a:prstGeom>
+          <a:noFill/>
+          <a:ln/>
+        </p:spPr>
+        <p:txBody>
+          <a:bodyPr wrap="square" lIns="0" tIns="0" rIns="0" bIns="0" rtlCol="0" anchor="ctr"/>
+          <a:lstStyle/>
+          <a:p>
+            <a:pPr algn="r" indent="0" marL="0">
+              <a:buNone/>
+            </a:pPr>
+            <a:r>
+              <a:rPr lang="en-US" sz="750" b="1" dirty="0">
+                <a:solidFill>
+                  <a:srgbClr val="7C3AED"/>
+                </a:solidFill>
+                <a:latin typeface="Calibri" pitchFamily="34" charset="0"/>
+                <a:ea typeface="Calibri" pitchFamily="34" charset="-122"/>
+                <a:cs typeface="Calibri" pitchFamily="34" charset="-120"/>
+              </a:rPr>
+              <a:t>LangGraph · 5 AGENTS</a:t>
+            </a:r>
+            <a:endParaRPr lang="en-US" sz="750" dirty="0"/>
+          </a:p>
+        </p:txBody>
+      </p:sp>
+      <p:sp>
+        <p:nvSpPr>
+          <p:cNvPr id="44" name="Shape 42"/>
           <p:cNvSpPr/>
           <p:nvPr/>
         </p:nvSpPr>
@@ -2239,14 +2317,14 @@
       </p:sp>
       <p:sp>
         <p:nvSpPr>
-          <p:cNvPr id="43" name="Text 41"/>
+          <p:cNvPr id="45" name="Text 43"/>
           <p:cNvSpPr txBox="1"/>
           <p:nvPr/>
         </p:nvSpPr>
         <p:spPr>
           <a:xfrm>
             <a:off x="8412480" y="2346960"/>
-            <a:ext cx="3307080" cy="121920"/>
+            <a:ext cx="2026920" cy="121920"/>
           </a:xfrm>
           <a:prstGeom prst="rect">
             <a:avLst/>
@@ -2270,7 +2348,7 @@
                 <a:ea typeface="Calibri" pitchFamily="34" charset="-122"/>
                 <a:cs typeface="Calibri" pitchFamily="34" charset="-120"/>
               </a:rPr>
-              <a:t>CASE AGENTS · police &amp; advocate</a:t>
+              <a:t>CASE &amp; INVESTIGATION · police &amp; advocate</a:t>
             </a:r>
             <a:endParaRPr lang="en-US" sz="900" dirty="0"/>
           </a:p>
@@ -2278,7 +2356,46 @@
       </p:sp>
       <p:sp>
         <p:nvSpPr>
-          <p:cNvPr id="44" name="Shape 42"/>
+          <p:cNvPr id="46" name="Text 44"/>
+          <p:cNvSpPr txBox="1"/>
+          <p:nvPr/>
+        </p:nvSpPr>
+        <p:spPr>
+          <a:xfrm>
+            <a:off x="10317480" y="2346960"/>
+            <a:ext cx="1417320" cy="121920"/>
+          </a:xfrm>
+          <a:prstGeom prst="rect">
+            <a:avLst/>
+          </a:prstGeom>
+          <a:noFill/>
+          <a:ln/>
+        </p:spPr>
+        <p:txBody>
+          <a:bodyPr wrap="square" lIns="0" tIns="0" rIns="0" bIns="0" rtlCol="0" anchor="ctr"/>
+          <a:lstStyle/>
+          <a:p>
+            <a:pPr algn="r" indent="0" marL="0">
+              <a:buNone/>
+            </a:pPr>
+            <a:r>
+              <a:rPr lang="en-US" sz="750" b="1" dirty="0">
+                <a:solidFill>
+                  <a:srgbClr val="16A34A"/>
+                </a:solidFill>
+                <a:latin typeface="Calibri" pitchFamily="34" charset="0"/>
+                <a:ea typeface="Calibri" pitchFamily="34" charset="-122"/>
+                <a:cs typeface="Calibri" pitchFamily="34" charset="-120"/>
+              </a:rPr>
+              <a:t>3 AGENTS · 2 SERVICES</a:t>
+            </a:r>
+            <a:endParaRPr lang="en-US" sz="750" dirty="0"/>
+          </a:p>
+        </p:txBody>
+      </p:sp>
+      <p:sp>
+        <p:nvSpPr>
+          <p:cNvPr id="47" name="Shape 45"/>
           <p:cNvSpPr/>
           <p:nvPr/>
         </p:nvSpPr>
@@ -2302,7 +2419,7 @@
       </p:sp>
       <p:sp>
         <p:nvSpPr>
-          <p:cNvPr id="45" name="Shape 43"/>
+          <p:cNvPr id="48" name="Shape 46"/>
           <p:cNvSpPr/>
           <p:nvPr/>
         </p:nvSpPr>
@@ -2326,7 +2443,7 @@
       </p:sp>
       <p:sp>
         <p:nvSpPr>
-          <p:cNvPr id="46" name="Shape 44"/>
+          <p:cNvPr id="49" name="Shape 47"/>
           <p:cNvSpPr/>
           <p:nvPr/>
         </p:nvSpPr>
@@ -2350,7 +2467,7 @@
       </p:sp>
       <p:sp>
         <p:nvSpPr>
-          <p:cNvPr id="47" name="Shape 45"/>
+          <p:cNvPr id="50" name="Shape 48"/>
           <p:cNvSpPr/>
           <p:nvPr/>
         </p:nvSpPr>
@@ -2377,7 +2494,7 @@
       </p:sp>
       <p:sp>
         <p:nvSpPr>
-          <p:cNvPr id="48" name="Text 46"/>
+          <p:cNvPr id="51" name="Text 49"/>
           <p:cNvSpPr txBox="1"/>
           <p:nvPr/>
         </p:nvSpPr>
@@ -2416,7 +2533,7 @@
       </p:sp>
       <p:sp>
         <p:nvSpPr>
-          <p:cNvPr id="49" name="Text 47"/>
+          <p:cNvPr id="52" name="Text 50"/>
           <p:cNvSpPr txBox="1"/>
           <p:nvPr/>
         </p:nvSpPr>
@@ -2455,7 +2572,7 @@
       </p:sp>
       <p:sp>
         <p:nvSpPr>
-          <p:cNvPr id="50" name="Shape 48"/>
+          <p:cNvPr id="53" name="Shape 51"/>
           <p:cNvSpPr/>
           <p:nvPr/>
         </p:nvSpPr>
@@ -2482,7 +2599,7 @@
       </p:sp>
       <p:sp>
         <p:nvSpPr>
-          <p:cNvPr id="51" name="Text 49"/>
+          <p:cNvPr id="54" name="Text 52"/>
           <p:cNvSpPr txBox="1"/>
           <p:nvPr/>
         </p:nvSpPr>
@@ -2521,7 +2638,7 @@
       </p:sp>
       <p:sp>
         <p:nvSpPr>
-          <p:cNvPr id="52" name="Text 50"/>
+          <p:cNvPr id="55" name="Text 53"/>
           <p:cNvSpPr txBox="1"/>
           <p:nvPr/>
         </p:nvSpPr>
@@ -2560,7 +2677,7 @@
       </p:sp>
       <p:sp>
         <p:nvSpPr>
-          <p:cNvPr id="53" name="Shape 51"/>
+          <p:cNvPr id="56" name="Shape 54"/>
           <p:cNvSpPr/>
           <p:nvPr/>
         </p:nvSpPr>
@@ -2584,7 +2701,7 @@
       </p:sp>
       <p:sp>
         <p:nvSpPr>
-          <p:cNvPr id="54" name="Shape 52"/>
+          <p:cNvPr id="57" name="Shape 55"/>
           <p:cNvSpPr/>
           <p:nvPr/>
         </p:nvSpPr>
@@ -2611,7 +2728,7 @@
       </p:sp>
       <p:sp>
         <p:nvSpPr>
-          <p:cNvPr id="55" name="Text 53"/>
+          <p:cNvPr id="58" name="Text 56"/>
           <p:cNvSpPr txBox="1"/>
           <p:nvPr/>
         </p:nvSpPr>
@@ -2650,7 +2767,7 @@
       </p:sp>
       <p:sp>
         <p:nvSpPr>
-          <p:cNvPr id="56" name="Text 54"/>
+          <p:cNvPr id="59" name="Text 57"/>
           <p:cNvSpPr txBox="1"/>
           <p:nvPr/>
         </p:nvSpPr>
@@ -2689,7 +2806,7 @@
       </p:sp>
       <p:sp>
         <p:nvSpPr>
-          <p:cNvPr id="57" name="Shape 55"/>
+          <p:cNvPr id="60" name="Shape 58"/>
           <p:cNvSpPr/>
           <p:nvPr/>
         </p:nvSpPr>
@@ -2713,7 +2830,7 @@
       </p:sp>
       <p:sp>
         <p:nvSpPr>
-          <p:cNvPr id="58" name="Shape 56"/>
+          <p:cNvPr id="61" name="Shape 59"/>
           <p:cNvSpPr/>
           <p:nvPr/>
         </p:nvSpPr>
@@ -2740,7 +2857,7 @@
       </p:sp>
       <p:sp>
         <p:nvSpPr>
-          <p:cNvPr id="59" name="Text 57"/>
+          <p:cNvPr id="62" name="Text 60"/>
           <p:cNvSpPr txBox="1"/>
           <p:nvPr/>
         </p:nvSpPr>
@@ -2779,7 +2896,7 @@
       </p:sp>
       <p:sp>
         <p:nvSpPr>
-          <p:cNvPr id="60" name="Text 58"/>
+          <p:cNvPr id="63" name="Text 61"/>
           <p:cNvSpPr txBox="1"/>
           <p:nvPr/>
         </p:nvSpPr>
@@ -2818,7 +2935,46 @@
       </p:sp>
       <p:sp>
         <p:nvSpPr>
-          <p:cNvPr id="61" name="Shape 59"/>
+          <p:cNvPr id="64" name="Text 62"/>
+          <p:cNvSpPr txBox="1"/>
+          <p:nvPr/>
+        </p:nvSpPr>
+        <p:spPr>
+          <a:xfrm>
+            <a:off x="6858000" y="2590800"/>
+            <a:ext cx="762000" cy="106680"/>
+          </a:xfrm>
+          <a:prstGeom prst="rect">
+            <a:avLst/>
+          </a:prstGeom>
+          <a:noFill/>
+          <a:ln/>
+        </p:spPr>
+        <p:txBody>
+          <a:bodyPr wrap="square" lIns="0" tIns="0" rIns="0" bIns="0" rtlCol="0" anchor="ctr"/>
+          <a:lstStyle/>
+          <a:p>
+            <a:pPr algn="r" indent="0" marL="0">
+              <a:buNone/>
+            </a:pPr>
+            <a:r>
+              <a:rPr lang="en-US" sz="700" b="1" dirty="0">
+                <a:solidFill>
+                  <a:srgbClr val="7C3AED"/>
+                </a:solidFill>
+                <a:latin typeface="Calibri" pitchFamily="34" charset="0"/>
+                <a:ea typeface="Calibri" pitchFamily="34" charset="-122"/>
+                <a:cs typeface="Calibri" pitchFamily="34" charset="-120"/>
+              </a:rPr>
+              <a:t>AGENT</a:t>
+            </a:r>
+            <a:endParaRPr lang="en-US" sz="700" dirty="0"/>
+          </a:p>
+        </p:txBody>
+      </p:sp>
+      <p:sp>
+        <p:nvSpPr>
+          <p:cNvPr id="65" name="Shape 63"/>
           <p:cNvSpPr/>
           <p:nvPr/>
         </p:nvSpPr>
@@ -2845,7 +3001,7 @@
       </p:sp>
       <p:sp>
         <p:nvSpPr>
-          <p:cNvPr id="62" name="Text 60"/>
+          <p:cNvPr id="66" name="Text 64"/>
           <p:cNvSpPr txBox="1"/>
           <p:nvPr/>
         </p:nvSpPr>
@@ -2884,7 +3040,7 @@
       </p:sp>
       <p:sp>
         <p:nvSpPr>
-          <p:cNvPr id="63" name="Text 61"/>
+          <p:cNvPr id="67" name="Text 65"/>
           <p:cNvSpPr txBox="1"/>
           <p:nvPr/>
         </p:nvSpPr>
@@ -2915,7 +3071,7 @@
                 <a:ea typeface="Calibri" pitchFamily="34" charset="-122"/>
                 <a:cs typeface="Calibri" pitchFamily="34" charset="-120"/>
               </a:rPr>
-              <a:t>rerank BGE-v2-m3 · citation following</a:t>
+              <a:t>hybrid search · citation following</a:t>
             </a:r>
             <a:endParaRPr lang="en-US" sz="800" dirty="0"/>
           </a:p>
@@ -2923,7 +3079,46 @@
       </p:sp>
       <p:sp>
         <p:nvSpPr>
-          <p:cNvPr id="64" name="Shape 62"/>
+          <p:cNvPr id="68" name="Text 66"/>
+          <p:cNvSpPr txBox="1"/>
+          <p:nvPr/>
+        </p:nvSpPr>
+        <p:spPr>
+          <a:xfrm>
+            <a:off x="6858000" y="3032760"/>
+            <a:ext cx="762000" cy="106680"/>
+          </a:xfrm>
+          <a:prstGeom prst="rect">
+            <a:avLst/>
+          </a:prstGeom>
+          <a:noFill/>
+          <a:ln/>
+        </p:spPr>
+        <p:txBody>
+          <a:bodyPr wrap="square" lIns="0" tIns="0" rIns="0" bIns="0" rtlCol="0" anchor="ctr"/>
+          <a:lstStyle/>
+          <a:p>
+            <a:pPr algn="r" indent="0" marL="0">
+              <a:buNone/>
+            </a:pPr>
+            <a:r>
+              <a:rPr lang="en-US" sz="700" b="1" dirty="0">
+                <a:solidFill>
+                  <a:srgbClr val="7C3AED"/>
+                </a:solidFill>
+                <a:latin typeface="Calibri" pitchFamily="34" charset="0"/>
+                <a:ea typeface="Calibri" pitchFamily="34" charset="-122"/>
+                <a:cs typeface="Calibri" pitchFamily="34" charset="-120"/>
+              </a:rPr>
+              <a:t>AGENT</a:t>
+            </a:r>
+            <a:endParaRPr lang="en-US" sz="700" dirty="0"/>
+          </a:p>
+        </p:txBody>
+      </p:sp>
+      <p:sp>
+        <p:nvSpPr>
+          <p:cNvPr id="69" name="Shape 67"/>
           <p:cNvSpPr/>
           <p:nvPr/>
         </p:nvSpPr>
@@ -2947,7 +3142,7 @@
       </p:sp>
       <p:sp>
         <p:nvSpPr>
-          <p:cNvPr id="65" name="Shape 63"/>
+          <p:cNvPr id="70" name="Shape 68"/>
           <p:cNvSpPr/>
           <p:nvPr/>
         </p:nvSpPr>
@@ -2974,7 +3169,7 @@
       </p:sp>
       <p:sp>
         <p:nvSpPr>
-          <p:cNvPr id="66" name="Text 64"/>
+          <p:cNvPr id="71" name="Text 69"/>
           <p:cNvSpPr txBox="1"/>
           <p:nvPr/>
         </p:nvSpPr>
@@ -3013,7 +3208,7 @@
       </p:sp>
       <p:sp>
         <p:nvSpPr>
-          <p:cNvPr id="67" name="Text 65"/>
+          <p:cNvPr id="72" name="Text 70"/>
           <p:cNvSpPr txBox="1"/>
           <p:nvPr/>
         </p:nvSpPr>
@@ -3052,7 +3247,46 @@
       </p:sp>
       <p:sp>
         <p:nvSpPr>
-          <p:cNvPr id="68" name="Shape 66"/>
+          <p:cNvPr id="73" name="Text 71"/>
+          <p:cNvSpPr txBox="1"/>
+          <p:nvPr/>
+        </p:nvSpPr>
+        <p:spPr>
+          <a:xfrm>
+            <a:off x="6858000" y="3474720"/>
+            <a:ext cx="762000" cy="106680"/>
+          </a:xfrm>
+          <a:prstGeom prst="rect">
+            <a:avLst/>
+          </a:prstGeom>
+          <a:noFill/>
+          <a:ln/>
+        </p:spPr>
+        <p:txBody>
+          <a:bodyPr wrap="square" lIns="0" tIns="0" rIns="0" bIns="0" rtlCol="0" anchor="ctr"/>
+          <a:lstStyle/>
+          <a:p>
+            <a:pPr algn="r" indent="0" marL="0">
+              <a:buNone/>
+            </a:pPr>
+            <a:r>
+              <a:rPr lang="en-US" sz="700" b="1" dirty="0">
+                <a:solidFill>
+                  <a:srgbClr val="7C3AED"/>
+                </a:solidFill>
+                <a:latin typeface="Calibri" pitchFamily="34" charset="0"/>
+                <a:ea typeface="Calibri" pitchFamily="34" charset="-122"/>
+                <a:cs typeface="Calibri" pitchFamily="34" charset="-120"/>
+              </a:rPr>
+              <a:t>AGENT</a:t>
+            </a:r>
+            <a:endParaRPr lang="en-US" sz="700" dirty="0"/>
+          </a:p>
+        </p:txBody>
+      </p:sp>
+      <p:sp>
+        <p:nvSpPr>
+          <p:cNvPr id="74" name="Shape 72"/>
           <p:cNvSpPr/>
           <p:nvPr/>
         </p:nvSpPr>
@@ -3076,7 +3310,7 @@
       </p:sp>
       <p:sp>
         <p:nvSpPr>
-          <p:cNvPr id="69" name="Shape 67"/>
+          <p:cNvPr id="75" name="Shape 73"/>
           <p:cNvSpPr/>
           <p:nvPr/>
         </p:nvSpPr>
@@ -3103,7 +3337,7 @@
       </p:sp>
       <p:sp>
         <p:nvSpPr>
-          <p:cNvPr id="70" name="Text 68"/>
+          <p:cNvPr id="76" name="Text 74"/>
           <p:cNvSpPr txBox="1"/>
           <p:nvPr/>
         </p:nvSpPr>
@@ -3142,7 +3376,7 @@
       </p:sp>
       <p:sp>
         <p:nvSpPr>
-          <p:cNvPr id="71" name="Text 69"/>
+          <p:cNvPr id="77" name="Text 75"/>
           <p:cNvSpPr txBox="1"/>
           <p:nvPr/>
         </p:nvSpPr>
@@ -3181,7 +3415,46 @@
       </p:sp>
       <p:sp>
         <p:nvSpPr>
-          <p:cNvPr id="72" name="Shape 70"/>
+          <p:cNvPr id="78" name="Text 76"/>
+          <p:cNvSpPr txBox="1"/>
+          <p:nvPr/>
+        </p:nvSpPr>
+        <p:spPr>
+          <a:xfrm>
+            <a:off x="6858000" y="3916680"/>
+            <a:ext cx="762000" cy="106680"/>
+          </a:xfrm>
+          <a:prstGeom prst="rect">
+            <a:avLst/>
+          </a:prstGeom>
+          <a:noFill/>
+          <a:ln/>
+        </p:spPr>
+        <p:txBody>
+          <a:bodyPr wrap="square" lIns="0" tIns="0" rIns="0" bIns="0" rtlCol="0" anchor="ctr"/>
+          <a:lstStyle/>
+          <a:p>
+            <a:pPr algn="r" indent="0" marL="0">
+              <a:buNone/>
+            </a:pPr>
+            <a:r>
+              <a:rPr lang="en-US" sz="700" b="1" dirty="0">
+                <a:solidFill>
+                  <a:srgbClr val="7C3AED"/>
+                </a:solidFill>
+                <a:latin typeface="Calibri" pitchFamily="34" charset="0"/>
+                <a:ea typeface="Calibri" pitchFamily="34" charset="-122"/>
+                <a:cs typeface="Calibri" pitchFamily="34" charset="-120"/>
+              </a:rPr>
+              <a:t>AGENT</a:t>
+            </a:r>
+            <a:endParaRPr lang="en-US" sz="700" dirty="0"/>
+          </a:p>
+        </p:txBody>
+      </p:sp>
+      <p:sp>
+        <p:nvSpPr>
+          <p:cNvPr id="79" name="Shape 77"/>
           <p:cNvSpPr/>
           <p:nvPr/>
         </p:nvSpPr>
@@ -3205,7 +3478,7 @@
       </p:sp>
       <p:sp>
         <p:nvSpPr>
-          <p:cNvPr id="73" name="Shape 71"/>
+          <p:cNvPr id="80" name="Shape 78"/>
           <p:cNvSpPr/>
           <p:nvPr/>
         </p:nvSpPr>
@@ -3232,7 +3505,7 @@
       </p:sp>
       <p:sp>
         <p:nvSpPr>
-          <p:cNvPr id="74" name="Text 72"/>
+          <p:cNvPr id="81" name="Text 79"/>
           <p:cNvSpPr txBox="1"/>
           <p:nvPr/>
         </p:nvSpPr>
@@ -3271,7 +3544,7 @@
       </p:sp>
       <p:sp>
         <p:nvSpPr>
-          <p:cNvPr id="75" name="Text 73"/>
+          <p:cNvPr id="82" name="Text 80"/>
           <p:cNvSpPr txBox="1"/>
           <p:nvPr/>
         </p:nvSpPr>
@@ -3310,7 +3583,46 @@
       </p:sp>
       <p:sp>
         <p:nvSpPr>
-          <p:cNvPr id="76" name="Shape 74"/>
+          <p:cNvPr id="83" name="Text 81"/>
+          <p:cNvSpPr txBox="1"/>
+          <p:nvPr/>
+        </p:nvSpPr>
+        <p:spPr>
+          <a:xfrm>
+            <a:off x="6858000" y="4358640"/>
+            <a:ext cx="762000" cy="106680"/>
+          </a:xfrm>
+          <a:prstGeom prst="rect">
+            <a:avLst/>
+          </a:prstGeom>
+          <a:noFill/>
+          <a:ln/>
+        </p:spPr>
+        <p:txBody>
+          <a:bodyPr wrap="square" lIns="0" tIns="0" rIns="0" bIns="0" rtlCol="0" anchor="ctr"/>
+          <a:lstStyle/>
+          <a:p>
+            <a:pPr algn="r" indent="0" marL="0">
+              <a:buNone/>
+            </a:pPr>
+            <a:r>
+              <a:rPr lang="en-US" sz="700" b="1" dirty="0">
+                <a:solidFill>
+                  <a:srgbClr val="7C3AED"/>
+                </a:solidFill>
+                <a:latin typeface="Calibri" pitchFamily="34" charset="0"/>
+                <a:ea typeface="Calibri" pitchFamily="34" charset="-122"/>
+                <a:cs typeface="Calibri" pitchFamily="34" charset="-120"/>
+              </a:rPr>
+              <a:t>AGENT</a:t>
+            </a:r>
+            <a:endParaRPr lang="en-US" sz="700" dirty="0"/>
+          </a:p>
+        </p:txBody>
+      </p:sp>
+      <p:sp>
+        <p:nvSpPr>
+          <p:cNvPr id="84" name="Shape 82"/>
           <p:cNvSpPr/>
           <p:nvPr/>
         </p:nvSpPr>
@@ -3334,7 +3646,7 @@
       </p:sp>
       <p:sp>
         <p:nvSpPr>
-          <p:cNvPr id="77" name="Shape 75"/>
+          <p:cNvPr id="85" name="Shape 83"/>
           <p:cNvSpPr/>
           <p:nvPr/>
         </p:nvSpPr>
@@ -3361,7 +3673,7 @@
       </p:sp>
       <p:sp>
         <p:nvSpPr>
-          <p:cNvPr id="78" name="Text 76"/>
+          <p:cNvPr id="86" name="Text 84"/>
           <p:cNvSpPr txBox="1"/>
           <p:nvPr/>
         </p:nvSpPr>
@@ -3392,7 +3704,7 @@
                 <a:ea typeface="Calibri" pitchFamily="34" charset="-122"/>
                 <a:cs typeface="Calibri" pitchFamily="34" charset="-120"/>
               </a:rPr>
-              <a:t>Document Analysis Agent</a:t>
+              <a:t>Document Analysis</a:t>
             </a:r>
             <a:endParaRPr lang="en-US" sz="1050" dirty="0"/>
           </a:p>
@@ -3400,7 +3712,7 @@
       </p:sp>
       <p:sp>
         <p:nvSpPr>
-          <p:cNvPr id="79" name="Text 77"/>
+          <p:cNvPr id="87" name="Text 85"/>
           <p:cNvSpPr txBox="1"/>
           <p:nvPr/>
         </p:nvSpPr>
@@ -3439,7 +3751,46 @@
       </p:sp>
       <p:sp>
         <p:nvSpPr>
-          <p:cNvPr id="80" name="Shape 78"/>
+          <p:cNvPr id="88" name="Text 86"/>
+          <p:cNvSpPr txBox="1"/>
+          <p:nvPr/>
+        </p:nvSpPr>
+        <p:spPr>
+          <a:xfrm>
+            <a:off x="10835640" y="2590800"/>
+            <a:ext cx="762000" cy="106680"/>
+          </a:xfrm>
+          <a:prstGeom prst="rect">
+            <a:avLst/>
+          </a:prstGeom>
+          <a:noFill/>
+          <a:ln/>
+        </p:spPr>
+        <p:txBody>
+          <a:bodyPr wrap="square" lIns="0" tIns="0" rIns="0" bIns="0" rtlCol="0" anchor="ctr"/>
+          <a:lstStyle/>
+          <a:p>
+            <a:pPr algn="r" indent="0" marL="0">
+              <a:buNone/>
+            </a:pPr>
+            <a:r>
+              <a:rPr lang="en-US" sz="700" b="1" dirty="0">
+                <a:solidFill>
+                  <a:srgbClr val="16A34A"/>
+                </a:solidFill>
+                <a:latin typeface="Calibri" pitchFamily="34" charset="0"/>
+                <a:ea typeface="Calibri" pitchFamily="34" charset="-122"/>
+                <a:cs typeface="Calibri" pitchFamily="34" charset="-120"/>
+              </a:rPr>
+              <a:t>SERVICE</a:t>
+            </a:r>
+            <a:endParaRPr lang="en-US" sz="700" dirty="0"/>
+          </a:p>
+        </p:txBody>
+      </p:sp>
+      <p:sp>
+        <p:nvSpPr>
+          <p:cNvPr id="89" name="Shape 87"/>
           <p:cNvSpPr/>
           <p:nvPr/>
         </p:nvSpPr>
@@ -3466,7 +3817,7 @@
       </p:sp>
       <p:sp>
         <p:nvSpPr>
-          <p:cNvPr id="81" name="Text 79"/>
+          <p:cNvPr id="90" name="Text 88"/>
           <p:cNvSpPr txBox="1"/>
           <p:nvPr/>
         </p:nvSpPr>
@@ -3505,7 +3856,7 @@
       </p:sp>
       <p:sp>
         <p:nvSpPr>
-          <p:cNvPr id="82" name="Text 80"/>
+          <p:cNvPr id="91" name="Text 89"/>
           <p:cNvSpPr txBox="1"/>
           <p:nvPr/>
         </p:nvSpPr>
@@ -3544,7 +3895,46 @@
       </p:sp>
       <p:sp>
         <p:nvSpPr>
-          <p:cNvPr id="83" name="Shape 81"/>
+          <p:cNvPr id="92" name="Text 90"/>
+          <p:cNvSpPr txBox="1"/>
+          <p:nvPr/>
+        </p:nvSpPr>
+        <p:spPr>
+          <a:xfrm>
+            <a:off x="10835640" y="3032760"/>
+            <a:ext cx="762000" cy="106680"/>
+          </a:xfrm>
+          <a:prstGeom prst="rect">
+            <a:avLst/>
+          </a:prstGeom>
+          <a:noFill/>
+          <a:ln/>
+        </p:spPr>
+        <p:txBody>
+          <a:bodyPr wrap="square" lIns="0" tIns="0" rIns="0" bIns="0" rtlCol="0" anchor="ctr"/>
+          <a:lstStyle/>
+          <a:p>
+            <a:pPr algn="r" indent="0" marL="0">
+              <a:buNone/>
+            </a:pPr>
+            <a:r>
+              <a:rPr lang="en-US" sz="700" b="1" dirty="0">
+                <a:solidFill>
+                  <a:srgbClr val="16A34A"/>
+                </a:solidFill>
+                <a:latin typeface="Calibri" pitchFamily="34" charset="0"/>
+                <a:ea typeface="Calibri" pitchFamily="34" charset="-122"/>
+                <a:cs typeface="Calibri" pitchFamily="34" charset="-120"/>
+              </a:rPr>
+              <a:t>AGENT</a:t>
+            </a:r>
+            <a:endParaRPr lang="en-US" sz="700" dirty="0"/>
+          </a:p>
+        </p:txBody>
+      </p:sp>
+      <p:sp>
+        <p:nvSpPr>
+          <p:cNvPr id="93" name="Shape 91"/>
           <p:cNvSpPr/>
           <p:nvPr/>
         </p:nvSpPr>
@@ -3568,7 +3958,7 @@
       </p:sp>
       <p:sp>
         <p:nvSpPr>
-          <p:cNvPr id="84" name="Shape 82"/>
+          <p:cNvPr id="94" name="Shape 92"/>
           <p:cNvSpPr/>
           <p:nvPr/>
         </p:nvSpPr>
@@ -3595,7 +3985,7 @@
       </p:sp>
       <p:sp>
         <p:nvSpPr>
-          <p:cNvPr id="85" name="Text 83"/>
+          <p:cNvPr id="95" name="Text 93"/>
           <p:cNvSpPr txBox="1"/>
           <p:nvPr/>
         </p:nvSpPr>
@@ -3626,7 +4016,7 @@
                 <a:ea typeface="Calibri" pitchFamily="34" charset="-122"/>
                 <a:cs typeface="Calibri" pitchFamily="34" charset="-120"/>
               </a:rPr>
-              <a:t>Timeline Agent</a:t>
+              <a:t>Timeline Builder</a:t>
             </a:r>
             <a:endParaRPr lang="en-US" sz="1050" dirty="0"/>
           </a:p>
@@ -3634,7 +4024,7 @@
       </p:sp>
       <p:sp>
         <p:nvSpPr>
-          <p:cNvPr id="86" name="Text 84"/>
+          <p:cNvPr id="96" name="Text 94"/>
           <p:cNvSpPr txBox="1"/>
           <p:nvPr/>
         </p:nvSpPr>
@@ -3673,7 +4063,46 @@
       </p:sp>
       <p:sp>
         <p:nvSpPr>
-          <p:cNvPr id="87" name="Shape 85"/>
+          <p:cNvPr id="97" name="Text 95"/>
+          <p:cNvSpPr txBox="1"/>
+          <p:nvPr/>
+        </p:nvSpPr>
+        <p:spPr>
+          <a:xfrm>
+            <a:off x="10835640" y="3474720"/>
+            <a:ext cx="762000" cy="106680"/>
+          </a:xfrm>
+          <a:prstGeom prst="rect">
+            <a:avLst/>
+          </a:prstGeom>
+          <a:noFill/>
+          <a:ln/>
+        </p:spPr>
+        <p:txBody>
+          <a:bodyPr wrap="square" lIns="0" tIns="0" rIns="0" bIns="0" rtlCol="0" anchor="ctr"/>
+          <a:lstStyle/>
+          <a:p>
+            <a:pPr algn="r" indent="0" marL="0">
+              <a:buNone/>
+            </a:pPr>
+            <a:r>
+              <a:rPr lang="en-US" sz="700" b="1" dirty="0">
+                <a:solidFill>
+                  <a:srgbClr val="16A34A"/>
+                </a:solidFill>
+                <a:latin typeface="Calibri" pitchFamily="34" charset="0"/>
+                <a:ea typeface="Calibri" pitchFamily="34" charset="-122"/>
+                <a:cs typeface="Calibri" pitchFamily="34" charset="-120"/>
+              </a:rPr>
+              <a:t>SERVICE</a:t>
+            </a:r>
+            <a:endParaRPr lang="en-US" sz="700" dirty="0"/>
+          </a:p>
+        </p:txBody>
+      </p:sp>
+      <p:sp>
+        <p:nvSpPr>
+          <p:cNvPr id="98" name="Shape 96"/>
           <p:cNvSpPr/>
           <p:nvPr/>
         </p:nvSpPr>
@@ -3697,7 +4126,7 @@
       </p:sp>
       <p:sp>
         <p:nvSpPr>
-          <p:cNvPr id="88" name="Shape 86"/>
+          <p:cNvPr id="99" name="Shape 97"/>
           <p:cNvSpPr/>
           <p:nvPr/>
         </p:nvSpPr>
@@ -3724,7 +4153,7 @@
       </p:sp>
       <p:sp>
         <p:nvSpPr>
-          <p:cNvPr id="89" name="Text 87"/>
+          <p:cNvPr id="100" name="Text 98"/>
           <p:cNvSpPr txBox="1"/>
           <p:nvPr/>
         </p:nvSpPr>
@@ -3755,7 +4184,7 @@
                 <a:ea typeface="Calibri" pitchFamily="34" charset="-122"/>
                 <a:cs typeface="Calibri" pitchFamily="34" charset="-120"/>
               </a:rPr>
-              <a:t>Compliance + Defence Agents</a:t>
+              <a:t>Compliance + Defence</a:t>
             </a:r>
             <a:endParaRPr lang="en-US" sz="1050" dirty="0"/>
           </a:p>
@@ -3763,7 +4192,7 @@
       </p:sp>
       <p:sp>
         <p:nvSpPr>
-          <p:cNvPr id="90" name="Text 88"/>
+          <p:cNvPr id="101" name="Text 99"/>
           <p:cNvSpPr txBox="1"/>
           <p:nvPr/>
         </p:nvSpPr>
@@ -3802,7 +4231,46 @@
       </p:sp>
       <p:sp>
         <p:nvSpPr>
-          <p:cNvPr id="91" name="Shape 89"/>
+          <p:cNvPr id="102" name="Text 100"/>
+          <p:cNvSpPr txBox="1"/>
+          <p:nvPr/>
+        </p:nvSpPr>
+        <p:spPr>
+          <a:xfrm>
+            <a:off x="10835640" y="3916680"/>
+            <a:ext cx="762000" cy="106680"/>
+          </a:xfrm>
+          <a:prstGeom prst="rect">
+            <a:avLst/>
+          </a:prstGeom>
+          <a:noFill/>
+          <a:ln/>
+        </p:spPr>
+        <p:txBody>
+          <a:bodyPr wrap="square" lIns="0" tIns="0" rIns="0" bIns="0" rtlCol="0" anchor="ctr"/>
+          <a:lstStyle/>
+          <a:p>
+            <a:pPr algn="r" indent="0" marL="0">
+              <a:buNone/>
+            </a:pPr>
+            <a:r>
+              <a:rPr lang="en-US" sz="700" b="1" dirty="0">
+                <a:solidFill>
+                  <a:srgbClr val="16A34A"/>
+                </a:solidFill>
+                <a:latin typeface="Calibri" pitchFamily="34" charset="0"/>
+                <a:ea typeface="Calibri" pitchFamily="34" charset="-122"/>
+                <a:cs typeface="Calibri" pitchFamily="34" charset="-120"/>
+              </a:rPr>
+              <a:t>SVC+AGENT</a:t>
+            </a:r>
+            <a:endParaRPr lang="en-US" sz="700" dirty="0"/>
+          </a:p>
+        </p:txBody>
+      </p:sp>
+      <p:sp>
+        <p:nvSpPr>
+          <p:cNvPr id="103" name="Shape 101"/>
           <p:cNvSpPr/>
           <p:nvPr/>
         </p:nvSpPr>
@@ -3826,7 +4294,7 @@
       </p:sp>
       <p:sp>
         <p:nvSpPr>
-          <p:cNvPr id="92" name="Shape 90"/>
+          <p:cNvPr id="104" name="Shape 102"/>
           <p:cNvSpPr/>
           <p:nvPr/>
         </p:nvSpPr>
@@ -3853,7 +4321,7 @@
       </p:sp>
       <p:sp>
         <p:nvSpPr>
-          <p:cNvPr id="93" name="Text 91"/>
+          <p:cNvPr id="105" name="Text 103"/>
           <p:cNvSpPr txBox="1"/>
           <p:nvPr/>
         </p:nvSpPr>
@@ -3892,7 +4360,7 @@
       </p:sp>
       <p:sp>
         <p:nvSpPr>
-          <p:cNvPr id="94" name="Text 92"/>
+          <p:cNvPr id="106" name="Text 104"/>
           <p:cNvSpPr txBox="1"/>
           <p:nvPr/>
         </p:nvSpPr>
@@ -3931,7 +4399,46 @@
       </p:sp>
       <p:sp>
         <p:nvSpPr>
-          <p:cNvPr id="95" name="Shape 93"/>
+          <p:cNvPr id="107" name="Text 105"/>
+          <p:cNvSpPr txBox="1"/>
+          <p:nvPr/>
+        </p:nvSpPr>
+        <p:spPr>
+          <a:xfrm>
+            <a:off x="10835640" y="4358640"/>
+            <a:ext cx="762000" cy="106680"/>
+          </a:xfrm>
+          <a:prstGeom prst="rect">
+            <a:avLst/>
+          </a:prstGeom>
+          <a:noFill/>
+          <a:ln/>
+        </p:spPr>
+        <p:txBody>
+          <a:bodyPr wrap="square" lIns="0" tIns="0" rIns="0" bIns="0" rtlCol="0" anchor="ctr"/>
+          <a:lstStyle/>
+          <a:p>
+            <a:pPr algn="r" indent="0" marL="0">
+              <a:buNone/>
+            </a:pPr>
+            <a:r>
+              <a:rPr lang="en-US" sz="700" b="1" dirty="0">
+                <a:solidFill>
+                  <a:srgbClr val="16A34A"/>
+                </a:solidFill>
+                <a:latin typeface="Calibri" pitchFamily="34" charset="0"/>
+                <a:ea typeface="Calibri" pitchFamily="34" charset="-122"/>
+                <a:cs typeface="Calibri" pitchFamily="34" charset="-120"/>
+              </a:rPr>
+              <a:t>AGENT</a:t>
+            </a:r>
+            <a:endParaRPr lang="en-US" sz="700" dirty="0"/>
+          </a:p>
+        </p:txBody>
+      </p:sp>
+      <p:sp>
+        <p:nvSpPr>
+          <p:cNvPr id="108" name="Shape 106"/>
           <p:cNvSpPr/>
           <p:nvPr/>
         </p:nvSpPr>
@@ -3955,7 +4462,7 @@
       </p:sp>
       <p:sp>
         <p:nvSpPr>
-          <p:cNvPr id="96" name="Shape 94"/>
+          <p:cNvPr id="109" name="Shape 107"/>
           <p:cNvSpPr/>
           <p:nvPr/>
         </p:nvSpPr>
@@ -3982,7 +4489,7 @@
       </p:sp>
       <p:sp>
         <p:nvSpPr>
-          <p:cNvPr id="97" name="Text 95"/>
+          <p:cNvPr id="110" name="Text 108"/>
           <p:cNvSpPr txBox="1"/>
           <p:nvPr/>
         </p:nvSpPr>
@@ -4021,7 +4528,7 @@
       </p:sp>
       <p:sp>
         <p:nvSpPr>
-          <p:cNvPr id="98" name="Text 96"/>
+          <p:cNvPr id="111" name="Text 109"/>
           <p:cNvSpPr txBox="1"/>
           <p:nvPr/>
         </p:nvSpPr>
@@ -4060,7 +4567,7 @@
       </p:sp>
       <p:sp>
         <p:nvSpPr>
-          <p:cNvPr id="99" name="Shape 97"/>
+          <p:cNvPr id="112" name="Shape 110"/>
           <p:cNvSpPr/>
           <p:nvPr/>
         </p:nvSpPr>
@@ -4084,7 +4591,7 @@
       </p:sp>
       <p:sp>
         <p:nvSpPr>
-          <p:cNvPr id="100" name="Shape 98"/>
+          <p:cNvPr id="113" name="Shape 111"/>
           <p:cNvSpPr/>
           <p:nvPr/>
         </p:nvSpPr>
@@ -4111,7 +4618,7 @@
       </p:sp>
       <p:sp>
         <p:nvSpPr>
-          <p:cNvPr id="101" name="Text 99"/>
+          <p:cNvPr id="114" name="Text 112"/>
           <p:cNvSpPr txBox="1"/>
           <p:nvPr/>
         </p:nvSpPr>
@@ -4150,7 +4657,7 @@
       </p:sp>
       <p:sp>
         <p:nvSpPr>
-          <p:cNvPr id="102" name="Text 100"/>
+          <p:cNvPr id="115" name="Text 113"/>
           <p:cNvSpPr txBox="1"/>
           <p:nvPr/>
         </p:nvSpPr>
@@ -4189,7 +4696,7 @@
       </p:sp>
       <p:sp>
         <p:nvSpPr>
-          <p:cNvPr id="103" name="Shape 101"/>
+          <p:cNvPr id="116" name="Shape 114"/>
           <p:cNvSpPr/>
           <p:nvPr/>
         </p:nvSpPr>
@@ -4213,7 +4720,7 @@
       </p:sp>
       <p:sp>
         <p:nvSpPr>
-          <p:cNvPr id="104" name="Shape 102"/>
+          <p:cNvPr id="117" name="Shape 115"/>
           <p:cNvSpPr/>
           <p:nvPr/>
         </p:nvSpPr>
@@ -4240,7 +4747,7 @@
       </p:sp>
       <p:sp>
         <p:nvSpPr>
-          <p:cNvPr id="105" name="Text 103"/>
+          <p:cNvPr id="118" name="Text 116"/>
           <p:cNvSpPr txBox="1"/>
           <p:nvPr/>
         </p:nvSpPr>
@@ -4279,7 +4786,7 @@
       </p:sp>
       <p:sp>
         <p:nvSpPr>
-          <p:cNvPr id="106" name="Text 104"/>
+          <p:cNvPr id="119" name="Text 117"/>
           <p:cNvSpPr txBox="1"/>
           <p:nvPr/>
         </p:nvSpPr>
@@ -4318,7 +4825,7 @@
       </p:sp>
       <p:sp>
         <p:nvSpPr>
-          <p:cNvPr id="107" name="Shape 105"/>
+          <p:cNvPr id="120" name="Shape 118"/>
           <p:cNvSpPr/>
           <p:nvPr/>
         </p:nvSpPr>
@@ -4342,7 +4849,55 @@
       </p:sp>
       <p:sp>
         <p:nvSpPr>
-          <p:cNvPr id="108" name="Shape 106"/>
+          <p:cNvPr id="121" name="Shape 119"/>
+          <p:cNvSpPr/>
+          <p:nvPr/>
+        </p:nvSpPr>
+        <p:spPr>
+          <a:xfrm flipH="1">
+            <a:off x="182880" y="1539240"/>
+            <a:ext cx="3246120" cy="0"/>
+          </a:xfrm>
+          <a:prstGeom prst="line">
+            <a:avLst/>
+          </a:prstGeom>
+          <a:noFill/>
+          <a:ln w="12700">
+            <a:solidFill>
+              <a:srgbClr val="64748B"/>
+            </a:solidFill>
+            <a:prstDash val="solid"/>
+            <a:tailEnd type="triangle"/>
+          </a:ln>
+        </p:spPr>
+      </p:sp>
+      <p:sp>
+        <p:nvSpPr>
+          <p:cNvPr id="122" name="Shape 120"/>
+          <p:cNvSpPr/>
+          <p:nvPr/>
+        </p:nvSpPr>
+        <p:spPr>
+          <a:xfrm>
+            <a:off x="182880" y="1539240"/>
+            <a:ext cx="0" cy="4236720"/>
+          </a:xfrm>
+          <a:prstGeom prst="line">
+            <a:avLst/>
+          </a:prstGeom>
+          <a:noFill/>
+          <a:ln w="12700">
+            <a:solidFill>
+              <a:srgbClr val="64748B"/>
+            </a:solidFill>
+            <a:prstDash val="solid"/>
+            <a:tailEnd type="triangle"/>
+          </a:ln>
+        </p:spPr>
+      </p:sp>
+      <p:sp>
+        <p:nvSpPr>
+          <p:cNvPr id="123" name="Shape 121"/>
           <p:cNvSpPr/>
           <p:nvPr/>
         </p:nvSpPr>
@@ -4369,7 +4924,7 @@
       </p:sp>
       <p:sp>
         <p:nvSpPr>
-          <p:cNvPr id="109" name="Text 107"/>
+          <p:cNvPr id="124" name="Text 122"/>
           <p:cNvSpPr txBox="1"/>
           <p:nvPr/>
         </p:nvSpPr>
@@ -4408,7 +4963,7 @@
       </p:sp>
       <p:sp>
         <p:nvSpPr>
-          <p:cNvPr id="110" name="Shape 108"/>
+          <p:cNvPr id="125" name="Shape 123"/>
           <p:cNvSpPr/>
           <p:nvPr/>
         </p:nvSpPr>
@@ -4435,7 +4990,7 @@
       </p:sp>
       <p:sp>
         <p:nvSpPr>
-          <p:cNvPr id="111" name="Text 109"/>
+          <p:cNvPr id="126" name="Text 124"/>
           <p:cNvSpPr txBox="1"/>
           <p:nvPr/>
         </p:nvSpPr>
@@ -4474,7 +5029,7 @@
       </p:sp>
       <p:sp>
         <p:nvSpPr>
-          <p:cNvPr id="112" name="Text 110"/>
+          <p:cNvPr id="127" name="Text 125"/>
           <p:cNvSpPr txBox="1"/>
           <p:nvPr/>
         </p:nvSpPr>
@@ -4513,7 +5068,7 @@
       </p:sp>
       <p:sp>
         <p:nvSpPr>
-          <p:cNvPr id="113" name="Shape 111"/>
+          <p:cNvPr id="128" name="Shape 126"/>
           <p:cNvSpPr/>
           <p:nvPr/>
         </p:nvSpPr>
@@ -4540,7 +5095,7 @@
       </p:sp>
       <p:sp>
         <p:nvSpPr>
-          <p:cNvPr id="114" name="Text 112"/>
+          <p:cNvPr id="129" name="Text 127"/>
           <p:cNvSpPr txBox="1"/>
           <p:nvPr/>
         </p:nvSpPr>
@@ -4579,7 +5134,7 @@
       </p:sp>
       <p:sp>
         <p:nvSpPr>
-          <p:cNvPr id="115" name="Text 113"/>
+          <p:cNvPr id="130" name="Text 128"/>
           <p:cNvSpPr txBox="1"/>
           <p:nvPr/>
         </p:nvSpPr>
@@ -4618,7 +5173,7 @@
       </p:sp>
       <p:sp>
         <p:nvSpPr>
-          <p:cNvPr id="116" name="Shape 114"/>
+          <p:cNvPr id="131" name="Shape 129"/>
           <p:cNvSpPr/>
           <p:nvPr/>
         </p:nvSpPr>
@@ -4645,7 +5200,7 @@
       </p:sp>
       <p:sp>
         <p:nvSpPr>
-          <p:cNvPr id="117" name="Text 115"/>
+          <p:cNvPr id="132" name="Text 130"/>
           <p:cNvSpPr txBox="1"/>
           <p:nvPr/>
         </p:nvSpPr>
@@ -4684,7 +5239,7 @@
       </p:sp>
       <p:sp>
         <p:nvSpPr>
-          <p:cNvPr id="118" name="Text 116"/>
+          <p:cNvPr id="133" name="Text 131"/>
           <p:cNvSpPr txBox="1"/>
           <p:nvPr/>
         </p:nvSpPr>
@@ -4715,7 +5270,7 @@
                 <a:ea typeface="Calibri" pitchFamily="34" charset="-122"/>
                 <a:cs typeface="Calibri" pitchFamily="34" charset="-120"/>
               </a:rPr>
-              <a:t>1,036 docs · 49,684 passages</a:t>
+              <a:t>global_legal_corpus_v4 · 1,036 docs</a:t>
             </a:r>
             <a:endParaRPr lang="en-US" sz="800" dirty="0"/>
           </a:p>
@@ -4723,7 +5278,7 @@
       </p:sp>
       <p:sp>
         <p:nvSpPr>
-          <p:cNvPr id="119" name="Shape 117"/>
+          <p:cNvPr id="134" name="Shape 132"/>
           <p:cNvSpPr/>
           <p:nvPr/>
         </p:nvSpPr>
@@ -4750,7 +5305,7 @@
       </p:sp>
       <p:sp>
         <p:nvSpPr>
-          <p:cNvPr id="120" name="Text 118"/>
+          <p:cNvPr id="135" name="Text 133"/>
           <p:cNvSpPr txBox="1"/>
           <p:nvPr/>
         </p:nvSpPr>
@@ -4789,7 +5344,7 @@
       </p:sp>
       <p:sp>
         <p:nvSpPr>
-          <p:cNvPr id="121" name="Text 119"/>
+          <p:cNvPr id="136" name="Text 134"/>
           <p:cNvSpPr txBox="1"/>
           <p:nvPr/>
         </p:nvSpPr>
@@ -4828,7 +5383,7 @@
       </p:sp>
       <p:sp>
         <p:nvSpPr>
-          <p:cNvPr id="122" name="Shape 120"/>
+          <p:cNvPr id="137" name="Shape 135"/>
           <p:cNvSpPr/>
           <p:nvPr/>
         </p:nvSpPr>
@@ -4855,7 +5410,7 @@
       </p:sp>
       <p:sp>
         <p:nvSpPr>
-          <p:cNvPr id="123" name="Text 121"/>
+          <p:cNvPr id="138" name="Text 136"/>
           <p:cNvSpPr txBox="1"/>
           <p:nvPr/>
         </p:nvSpPr>
@@ -4894,7 +5449,7 @@
       </p:sp>
       <p:sp>
         <p:nvSpPr>
-          <p:cNvPr id="124" name="Text 122"/>
+          <p:cNvPr id="139" name="Text 137"/>
           <p:cNvSpPr txBox="1"/>
           <p:nvPr/>
         </p:nvSpPr>
@@ -4925,7 +5480,7 @@
                 <a:ea typeface="Calibri" pitchFamily="34" charset="-122"/>
                 <a:cs typeface="Calibri" pitchFamily="34" charset="-120"/>
               </a:rPr>
-              <a:t>BGE-M3 · IPC/CrPC/IEA → Sanhitas</a:t>
+              <a:t>BGE-M3 hybrid + RRF · IPC/CrPC → Sanhitas</a:t>
             </a:r>
             <a:endParaRPr lang="en-US" sz="800" dirty="0"/>
           </a:p>
@@ -4933,7 +5488,7 @@
       </p:sp>
       <p:sp>
         <p:nvSpPr>
-          <p:cNvPr id="125" name="Shape 123"/>
+          <p:cNvPr id="140" name="Shape 138"/>
           <p:cNvSpPr/>
           <p:nvPr/>
         </p:nvSpPr>
@@ -4960,7 +5515,7 @@
       </p:sp>
       <p:sp>
         <p:nvSpPr>
-          <p:cNvPr id="126" name="Text 124"/>
+          <p:cNvPr id="141" name="Text 139"/>
           <p:cNvSpPr txBox="1"/>
           <p:nvPr/>
         </p:nvSpPr>
@@ -4999,7 +5554,7 @@
       </p:sp>
       <p:sp>
         <p:nvSpPr>
-          <p:cNvPr id="127" name="Text 125"/>
+          <p:cNvPr id="142" name="Text 140"/>
           <p:cNvSpPr txBox="1"/>
           <p:nvPr/>
         </p:nvSpPr>
@@ -5038,7 +5593,7 @@
       </p:sp>
       <p:sp>
         <p:nvSpPr>
-          <p:cNvPr id="128" name="Shape 126"/>
+          <p:cNvPr id="143" name="Shape 141"/>
           <p:cNvSpPr/>
           <p:nvPr/>
         </p:nvSpPr>
@@ -5062,7 +5617,7 @@
       </p:sp>
       <p:sp>
         <p:nvSpPr>
-          <p:cNvPr id="129" name="Shape 127"/>
+          <p:cNvPr id="144" name="Shape 142"/>
           <p:cNvSpPr/>
           <p:nvPr/>
         </p:nvSpPr>
@@ -5086,7 +5641,7 @@
       </p:sp>
       <p:sp>
         <p:nvSpPr>
-          <p:cNvPr id="130" name="Shape 128"/>
+          <p:cNvPr id="145" name="Shape 143"/>
           <p:cNvSpPr/>
           <p:nvPr/>
         </p:nvSpPr>
@@ -5110,7 +5665,7 @@
       </p:sp>
       <p:sp>
         <p:nvSpPr>
-          <p:cNvPr id="131" name="Text 129"/>
+          <p:cNvPr id="146" name="Text 144"/>
           <p:cNvSpPr txBox="1"/>
           <p:nvPr/>
         </p:nvSpPr>
@@ -5141,7 +5696,7 @@
                 <a:ea typeface="Calibri" pitchFamily="34" charset="-122"/>
                 <a:cs typeface="Calibri" pitchFamily="34" charset="-120"/>
               </a:rPr>
-              <a:t>Data flow ──▶    Retry / refusal ╌╌▶    Gemini Flash is configured first and is NOT WIRED yet; Ollama qwen3-14b-16k serves every request today</a:t>
+              <a:t>Data flow ──▶   Retry / refusal ╬╬▶   AGENT = backend/app/agents/   ·   Fast calls no LLM (fast_research.py:408)   ·   Cross-encoder reranking is OFF: +5,126 ms/query, R@1 0.69→0.64 (config.py:62)   ·   Gemini NOT WIRED — Ollama qwen3-14b-16k serves every request</a:t>
             </a:r>
             <a:endParaRPr lang="en-US" sz="800" dirty="0"/>
           </a:p>

</xml_diff>

<commit_message>
fix(ci): load corpus metadata and OCR dependencies
</commit_message>
<xml_diff>
--- a/docs/presentations/Corpusil_Architecture_Slide.pptx
+++ b/docs/presentations/Corpusil_Architecture_Slide.pptx
@@ -947,7 +947,7 @@
                 <a:ea typeface="Calibri" pitchFamily="34" charset="-122"/>
                 <a:cs typeface="Calibri" pitchFamily="34" charset="-120"/>
               </a:rPr>
-              <a:t>Indian law · one request, three journeys, three outputs · 1,036 documents · 49,684 indexed passages</a:t>
+              <a:t>Indian law · one request, three journeys, three outputs · 1,036 canonical documents from 38 official publishers</a:t>
             </a:r>
             <a:endParaRPr lang="en-US" sz="900" dirty="0"/>
           </a:p>
@@ -5021,7 +5021,7 @@
                 <a:ea typeface="Calibri" pitchFamily="34" charset="-122"/>
                 <a:cs typeface="Calibri" pitchFamily="34" charset="-120"/>
               </a:rPr>
-              <a:t>Acquisition</a:t>
+              <a:t>Acquisition + Validation</a:t>
             </a:r>
             <a:endParaRPr lang="en-US" sz="1050" dirty="0"/>
           </a:p>
@@ -5060,7 +5060,7 @@
                 <a:ea typeface="Calibri" pitchFamily="34" charset="-122"/>
                 <a:cs typeface="Calibri" pitchFamily="34" charset="-120"/>
               </a:rPr>
-              <a:t>India Code · High Courts · NALSA</a:t>
+              <a:t>38 .gov.in publishers · 90 quarantined</a:t>
             </a:r>
             <a:endParaRPr lang="en-US" sz="800" dirty="0"/>
           </a:p>
@@ -5696,7 +5696,7 @@
                 <a:ea typeface="Calibri" pitchFamily="34" charset="-122"/>
                 <a:cs typeface="Calibri" pitchFamily="34" charset="-120"/>
               </a:rPr>
-              <a:t>Data flow ──▶   Retry / refusal ╬╬▶   AGENT = backend/app/agents/   ·   Fast calls no LLM (fast_research.py:408)   ·   Cross-encoder reranking is OFF: +5,126 ms/query, R@1 0.69→0.64 (config.py:62)   ·   Gemini NOT WIRED — Ollama qwen3-14b-16k serves every request</a:t>
+              <a:t>Data flow ──▶   Retry / refusal ╬╬▶   AGENT = backend/app/agents/   ·   Fast calls no LLM (fast_research.py:408)   ·   Cross-encoder reranking OFF: +5,126 ms/query, no significant accuracy change (McNemar p≥0.50)   ·   Gemini NOT WIRED — Ollama qwen3-14b-16k serves every request</a:t>
             </a:r>
             <a:endParaRPr lang="en-US" sz="800" dirty="0"/>
           </a:p>

</xml_diff>